<commit_message>
Add business case to report and presentations
</commit_message>
<xml_diff>
--- a/unterlagen/FHGR_PQD_Moodle Scraping.pptx
+++ b/unterlagen/FHGR_PQD_Moodle Scraping.pptx
@@ -13139,7 +13139,7 @@
                       </a:r>
                       <a:r>
                         <a:rPr lang="de-CH" sz="1000" dirty="0"/>
-                        <a:t> Der Prozess spart ca. 35 Stunden pro Semester ein.</a:t>
+                        <a:t> Manuell 35h/Semester, automatisiert ca. 4.7h Kontrollaufwand. Nettoersparnis ca. 30.3h bzw. CHF 1'213 pro Semester bei CHF 40/h.</a:t>
                       </a:r>
                     </a:p>
                     <a:p>
@@ -14117,7 +14117,7 @@
                       </a:r>
                       <a:r>
                         <a:rPr lang="de-CH" sz="1000" dirty="0"/>
-                        <a:t> Der Prozess spart ca. 35 Stunden pro Semester ein.</a:t>
+                        <a:t> Manuell 35h/Semester, automatisiert ca. 4.7h Kontrollaufwand. Nettoersparnis ca. 30.3h bzw. CHF 1'213 pro Semester bei CHF 40/h.</a:t>
                       </a:r>
                     </a:p>
                     <a:p>
@@ -16430,7 +16430,7 @@
                           <a:ea typeface="+mn-ea"/>
                           <a:cs typeface="+mn-cs"/>
                         </a:rPr>
-                        <a:t> Ermöglicht die schnelle Bearbeitung von bis zu 20 Kursplanungen pro Woche ohne zusätzlichen personellen Aufwand.</a:t>
+                        <a:t> Ermöglicht die schnelle Bearbeitung von bis zu 20 Kursplanungen pro Woche. Bei 140 Fällen pro Semester sinkt der Aufwand von 35h auf ca. 4.7h Kontrollzeit.</a:t>
                       </a:r>
                     </a:p>
                     <a:p>
@@ -19103,7 +19103,7 @@
                           <a:ea typeface="+mn-ea"/>
                           <a:cs typeface="+mn-cs"/>
                         </a:rPr>
-                        <a:t>Reporting:</a:t>
+                        <a:t>Business Case:</a:t>
                       </a:r>
                       <a:r>
                         <a:rPr lang="de-CH" sz="1200" kern="1200" dirty="0">
@@ -19115,7 +19115,7 @@
                           <a:ea typeface="+mn-ea"/>
                           <a:cs typeface="+mn-cs"/>
                         </a:rPr>
-                        <a:t> Nach erfolgreichem Durchlauf erfolgt der automatische Versand des Lernplans als PDF-Bericht per E-Mail an den Benutzer.</a:t>
+                        <a:t> Einmaliger Aufbau ca. 35h / CHF 1'400. Laufende Ersparnis ca. 30.3h / CHF 1'213 pro Semester; Payback ca. 1.2 Semester.</a:t>
                       </a:r>
                     </a:p>
                     <a:p>

</xml_diff>